<commit_message>
Point to the experiment branch in README, report and slides
</commit_message>
<xml_diff>
--- a/report/presentation.pptx
+++ b/report/presentation.pptx
@@ -119,14 +119,14 @@
   <p:extLst>
     <p:ext uri="{521415D9-36F7-43E2-AB2F-B90AF26B5E84}">
       <p14:sectionLst xmlns:p14="http://schemas.microsoft.com/office/powerpoint/2010/main">
-        <p14:section name="Introduction" id="{d486c980-481b-802b-83c2-868db0496add}">
+        <p14:section name="Introduction" id="{9ca0207b-d419-3b25-0955-febfac341f28}">
           <p14:sldIdLst>
             <p14:sldId id="256"/>
             <p14:sldId id="257"/>
             <p14:sldId id="258"/>
           </p14:sldIdLst>
         </p14:section>
-        <p14:section name="Reproduction" id="{48c5713d-3979-8dad-fca3-348767ddf65b}">
+        <p14:section name="Reproduction" id="{fd7aba33-d8ee-197e-259a-a78161817376}">
           <p14:sldIdLst>
             <p14:sldId id="259"/>
             <p14:sldId id="260"/>
@@ -134,7 +134,7 @@
             <p14:sldId id="262"/>
           </p14:sldIdLst>
         </p14:section>
-        <p14:section name="Experiment" id="{7641899c-19e1-1f48-09ab-1fca87565091}">
+        <p14:section name="Experiment" id="{86cd57b0-1710-f6be-842d-7719c952ff37}">
           <p14:sldIdLst>
             <p14:sldId id="263"/>
             <p14:sldId id="264"/>
@@ -142,12 +142,12 @@
             <p14:sldId id="266"/>
           </p14:sldIdLst>
         </p14:section>
-        <p14:section name="Deployment" id="{1ec01067-383f-44d0-8676-ee0a8d8948b0}">
+        <p14:section name="Deployment" id="{f3ffdccb-39dd-ce07-1f5d-927ba1b2e3c3}">
           <p14:sldIdLst>
             <p14:sldId id="267"/>
           </p14:sldIdLst>
         </p14:section>
-        <p14:section name="Conclusion" id="{468b0098-f53a-6235-ee36-41cc1b0c996d}">
+        <p14:section name="Conclusion" id="{26add3d8-e768-6477-27dc-cfb44dfb64ad}">
           <p14:sldIdLst>
             <p14:sldId id="268"/>
           </p14:sldIdLst>
@@ -6123,7 +6123,7 @@
                   <a:schemeClr val="tx1"/>
                 </a:solidFill>
               </a:rPr>
-              <a:t>Train ViTs of growing size with 0 and 4 registers and measure whether artifacts appear.</a:t>
+              <a:t>Train ViTs of growing size with 0 and 4 registers and measure whether artifacts appear. Branch: experiment-model-size.</a:t>
             </a:r>
             <a:endParaRPr lang="en-US" sz="1400" dirty="0"/>
           </a:p>

</xml_diff>